<commit_message>
docs(gost): update culprit-guessing results (suspects held-out) and PR #30 frame-rate measurement
</commit_message>
<xml_diff>
--- a/docs/gost/09-prezentaciya.pptx
+++ b/docs/gost/09-prezentaciya.pptx
@@ -620,7 +620,7 @@
                 <a:latin typeface="Arial"/>
                 <a:cs typeface="Arial"/>
               </a:rPr>
-              <a:t>Угадывание виновного: не включено</a:t>
+              <a:t>Угадывание виновного: ненадёжно</a:t>
             </a:r>
           </a:p>
         </p:txBody>
@@ -652,7 +652,7 @@
                 <a:spcPts val="0"/>
               </a:spcBef>
               <a:spcAft>
-                <a:spcPts val="468"/>
+                <a:spcPts val="312"/>
               </a:spcAft>
               <a:buNone/>
             </a:pPr>
@@ -664,16 +664,16 @@
                 <a:latin typeface="Arial"/>
                 <a:cs typeface="Arial"/>
               </a:rPr>
-              <a:t>Исследовательский режим, выключен по умолчанию.</a:t>
-            </a:r>
-          </a:p>
-          <a:p>
-            <a:pPr algn="l" marL="0" indent="0">
-              <a:spcBef>
-                <a:spcPts val="0"/>
-              </a:spcBef>
-              <a:spcAft>
-                <a:spcPts val="468"/>
+              <a:t>Тест (8 рассказов, один прогон): ни один метод не лучше простых.</a:t>
+            </a:r>
+          </a:p>
+          <a:p>
+            <a:pPr algn="l" marL="0" indent="0">
+              <a:spcBef>
+                <a:spcPts val="0"/>
+              </a:spcBef>
+              <a:spcAft>
+                <a:spcPts val="312"/>
               </a:spcAft>
               <a:buNone/>
             </a:pPr>
@@ -685,16 +685,16 @@
                 <a:latin typeface="Arial"/>
                 <a:cs typeface="Arial"/>
               </a:rPr>
-              <a:t>На отложенных вопросах (8): верный виновник назван 1 раз.</a:t>
-            </a:r>
-          </a:p>
-          <a:p>
-            <a:pPr algn="l" marL="0" indent="0">
-              <a:spcBef>
-                <a:spcPts val="0"/>
-              </a:spcBef>
-              <a:spcAft>
-                <a:spcPts val="468"/>
+              <a:t>Dev (8): лучший из ~35 вариантов угадал 4 из 8 – цифра завышена.</a:t>
+            </a:r>
+          </a:p>
+          <a:p>
+            <a:pPr algn="l" marL="0" indent="0">
+              <a:spcBef>
+                <a:spcPts val="0"/>
+              </a:spcBef>
+              <a:spcAft>
+                <a:spcPts val="312"/>
               </a:spcAft>
               <a:buNone/>
             </a:pPr>
@@ -706,16 +706,16 @@
                 <a:latin typeface="Arial"/>
                 <a:cs typeface="Arial"/>
               </a:rPr>
-              <a:t>Простой режим без него: 2 раза из 8.</a:t>
-            </a:r>
-          </a:p>
-          <a:p>
-            <a:pPr algn="l" marL="0" indent="0">
-              <a:spcBef>
-                <a:spcPts val="0"/>
-              </a:spcBef>
-              <a:spcAft>
-                <a:spcPts val="468"/>
+              <a:t>6 новых рассказов: верно 2 из 6, как у «самого упоминаемого».</a:t>
+            </a:r>
+          </a:p>
+          <a:p>
+            <a:pPr algn="l" marL="0" indent="0">
+              <a:spcBef>
+                <a:spcPts val="0"/>
+              </a:spcBef>
+              <a:spcAft>
+                <a:spcPts val="312"/>
               </a:spcAft>
               <a:buNone/>
             </a:pPr>
@@ -727,16 +727,16 @@
                 <a:latin typeface="Arial"/>
                 <a:cs typeface="Arial"/>
               </a:rPr>
-              <a:t>Невиновного режим назвал в 2 ответах из 8.</a:t>
-            </a:r>
-          </a:p>
-          <a:p>
-            <a:pPr algn="l" marL="0" indent="0">
-              <a:spcBef>
-                <a:spcPts val="0"/>
-              </a:spcBef>
-              <a:spcAft>
-                <a:spcPts val="468"/>
+              <a:t>Интервал 0,10–0,70; один оправданный назван первым.</a:t>
+            </a:r>
+          </a:p>
+          <a:p>
+            <a:pPr algn="l" marL="0" indent="0">
+              <a:spcBef>
+                <a:spcPts val="0"/>
+              </a:spcBef>
+              <a:spcAft>
+                <a:spcPts val="312"/>
               </a:spcAft>
               <a:buNone/>
             </a:pPr>
@@ -748,7 +748,7 @@
                 <a:latin typeface="Arial"/>
                 <a:cs typeface="Arial"/>
               </a:rPr>
-              <a:t>Вывод: пользоваться нельзя.</a:t>
+              <a:t>Не обвиняет невиновного – только ценой отказов.</a:t>
             </a:r>
           </a:p>
         </p:txBody>
@@ -761,8 +761,8 @@
         </p:nvSpPr>
         <p:spPr>
           <a:xfrm>
-            <a:off x="640080" y="5760720"/>
-            <a:ext cx="10881360" cy="457200"/>
+            <a:off x="640080" y="5486400"/>
+            <a:ext cx="10881360" cy="731520"/>
           </a:xfrm>
           <a:prstGeom prst="rect">
             <a:avLst/>
@@ -792,7 +792,7 @@
                 <a:latin typeface="Arial"/>
                 <a:cs typeface="Arial"/>
               </a:rPr>
-              <a:t>Мало данных: выборка из 8 вопросов, метки ИИ, лексическая проверка.</a:t>
+              <a:t>Метки поставил ИИ, нужна проверка человеком. Ветка feat/suspects-matrix, в main её нет.</a:t>
             </a:r>
           </a:p>
         </p:txBody>
@@ -1228,7 +1228,7 @@
                 <a:latin typeface="Arial"/>
                 <a:cs typeface="Arial"/>
               </a:rPr>
-              <a:t>docs/spike/results/entity-answer-2026-10-29.md</a:t>
+              <a:t>suspects-20261030.md (ветка feat/suspects-matrix)</a:t>
             </a:r>
           </a:p>
           <a:p>
@@ -1249,7 +1249,7 @@
                 <a:latin typeface="Arial"/>
                 <a:cs typeface="Arial"/>
               </a:rPr>
-              <a:t>Комплект документации: docs/gost/</a:t>
+              <a:t>PR #30 на GitHub: описание измерений</a:t>
             </a:r>
           </a:p>
         </p:txBody>
@@ -4083,7 +4083,7 @@
                 <a:spcPts val="0"/>
               </a:spcBef>
               <a:spcAft>
-                <a:spcPts val="468"/>
+                <a:spcPts val="312"/>
               </a:spcAft>
               <a:buNone/>
             </a:pPr>
@@ -4095,16 +4095,16 @@
                 <a:latin typeface="Arial"/>
                 <a:cs typeface="Arial"/>
               </a:rPr>
-              <a:t>Ответ на ноутбуке без GPU: медиана 28,4 с (18,6–44,1 с).</a:t>
-            </a:r>
-          </a:p>
-          <a:p>
-            <a:pPr algn="l" marL="0" indent="0">
-              <a:spcBef>
-                <a:spcPts val="0"/>
-              </a:spcBef>
-              <a:spcAft>
-                <a:spcPts val="468"/>
+              <a:t>Ответ на ноутбуке без GPU: медиана 28,4 с (замер не в чистом окне).</a:t>
+            </a:r>
+          </a:p>
+          <a:p>
+            <a:pPr algn="l" marL="0" indent="0">
+              <a:spcBef>
+                <a:spcPts val="0"/>
+              </a:spcBef>
+              <a:spcAft>
+                <a:spcPts val="312"/>
               </a:spcAft>
               <a:buNone/>
             </a:pPr>
@@ -4116,16 +4116,16 @@
                 <a:latin typeface="Arial"/>
                 <a:cs typeface="Arial"/>
               </a:rPr>
-              <a:t>Замер не в чистом окне, поэтому это верхняя оценка.</a:t>
-            </a:r>
-          </a:p>
-          <a:p>
-            <a:pPr algn="l" marL="0" indent="0">
-              <a:spcBef>
-                <a:spcPts val="0"/>
-              </a:spcBef>
-              <a:spcAft>
-                <a:spcPts val="468"/>
+              <a:t>Доска, 14 карточек: сдвиг 2400 → 225 мс, масштаб 2100 → 315 мс.</a:t>
+            </a:r>
+          </a:p>
+          <a:p>
+            <a:pPr algn="l" marL="0" indent="0">
+              <a:spcBef>
+                <a:spcPts val="0"/>
+              </a:spcBef>
+              <a:spcAft>
+                <a:spcPts val="312"/>
               </a:spcAft>
               <a:buNone/>
             </a:pPr>
@@ -4137,16 +4137,16 @@
                 <a:latin typeface="Arial"/>
                 <a:cs typeface="Arial"/>
               </a:rPr>
-              <a:t>Доска: ускорена прорисовка при масштабировании (PR #30); кадры в секунду не измерены.</a:t>
-            </a:r>
-          </a:p>
-          <a:p>
-            <a:pPr algn="l" marL="0" indent="0">
-              <a:spcBef>
-                <a:spcPts val="0"/>
-              </a:spcBef>
-              <a:spcAft>
-                <a:spcPts val="468"/>
+              <a:t>Доска, 200 узлов: сдвиг 2060 → 384 мс, масштаб 13 900 → 2 780 мс.</a:t>
+            </a:r>
+          </a:p>
+          <a:p>
+            <a:pPr algn="l" marL="0" indent="0">
+              <a:spcBef>
+                <a:spcPts val="0"/>
+              </a:spcBef>
+              <a:spcAft>
+                <a:spcPts val="312"/>
               </a:spcAft>
               <a:buNone/>
             </a:pPr>
@@ -4158,14 +4158,79 @@
                 <a:latin typeface="Arial"/>
                 <a:cs typeface="Arial"/>
               </a:rPr>
-              <a:t>Автотесты: 986 прошли за 9,6 с (проверено 30.10.2026).</a:t>
-            </a:r>
-          </a:p>
-        </p:txBody>
-      </p:sp>
-      <p:sp>
-        <p:nvSpPr>
-          <p:cNvPr id="4" name="Номер слайда"/>
+              <a:t>Шум на масштабе большой; на ноутбуке не измерено.</a:t>
+            </a:r>
+          </a:p>
+          <a:p>
+            <a:pPr algn="l" marL="0" indent="0">
+              <a:spcBef>
+                <a:spcPts val="0"/>
+              </a:spcBef>
+              <a:spcAft>
+                <a:spcPts val="312"/>
+              </a:spcAft>
+              <a:buNone/>
+            </a:pPr>
+            <a:r>
+              <a:rPr lang="ru-RU" sz="2600" b="0" i="0" dirty="0">
+                <a:solidFill>
+                  <a:srgbClr val="111111"/>
+                </a:solidFill>
+                <a:latin typeface="Arial"/>
+                <a:cs typeface="Arial"/>
+              </a:rPr>
+              <a:t>Автотесты: 986 прошли за 9,6 с.</a:t>
+            </a:r>
+          </a:p>
+        </p:txBody>
+      </p:sp>
+      <p:sp>
+        <p:nvSpPr>
+          <p:cNvPr id="4" name="Примечание"/>
+          <p:cNvSpPr txBox="1"/>
+          <p:nvPr/>
+        </p:nvSpPr>
+        <p:spPr>
+          <a:xfrm>
+            <a:off x="640080" y="5486400"/>
+            <a:ext cx="10881360" cy="731520"/>
+          </a:xfrm>
+          <a:prstGeom prst="rect">
+            <a:avLst/>
+          </a:prstGeom>
+          <a:noFill/>
+        </p:spPr>
+        <p:txBody>
+          <a:bodyPr wrap="square" lIns="0" tIns="0" rIns="0" bIns="0" anchor="t">
+            <a:noAutofit/>
+          </a:bodyPr>
+          <a:lstStyle/>
+          <a:p>
+            <a:pPr algn="l" marL="0" indent="0">
+              <a:spcBef>
+                <a:spcPts val="0"/>
+              </a:spcBef>
+              <a:spcAft>
+                <a:spcPts val="0"/>
+              </a:spcAft>
+              <a:buNone/>
+            </a:pPr>
+            <a:r>
+              <a:rPr lang="ru-RU" sz="1600" b="0" i="0" dirty="0">
+                <a:solidFill>
+                  <a:srgbClr val="595959"/>
+                </a:solidFill>
+                <a:latin typeface="Arial"/>
+                <a:cs typeface="Arial"/>
+              </a:rPr>
+              <a:t>PR #30: время растеризации, headless Chromium, скриптовые сдвиг и масштаб. В покое картинка прежняя (отличие 1,5 из 255).</a:t>
+            </a:r>
+          </a:p>
+        </p:txBody>
+      </p:sp>
+      <p:sp>
+        <p:nvSpPr>
+          <p:cNvPr id="5" name="Номер слайда"/>
           <p:cNvSpPr txBox="1"/>
           <p:nvPr/>
         </p:nvSpPr>

</xml_diff>

<commit_message>
docs(gost): rebuild for the PR branch (541 files incl. suspects), neutral wording, no tool-specific mentions
</commit_message>
<xml_diff>
--- a/docs/gost/09-prezentaciya.pptx
+++ b/docs/gost/09-prezentaciya.pptx
@@ -792,7 +792,7 @@
                 <a:latin typeface="Arial"/>
                 <a:cs typeface="Arial"/>
               </a:rPr>
-              <a:t>Метки поставил ИИ, нужна проверка человеком. Ветка feat/suspects-matrix, в main её нет.</a:t>
+              <a:t>Метки поставил ИИ, нужна проверка человеком. Эксперимент, в основной путь ответов не включён.</a:t>
             </a:r>
           </a:p>
         </p:txBody>
@@ -1228,7 +1228,7 @@
                 <a:latin typeface="Arial"/>
                 <a:cs typeface="Arial"/>
               </a:rPr>
-              <a:t>suspects-20261030.md (ветка feat/suspects-matrix)</a:t>
+              <a:t>suspects-20261030.md</a:t>
             </a:r>
           </a:p>
           <a:p>

</xml_diff>

<commit_message>
docs(gost): drop authorship statements, label data as auto-labelled and unreviewed, curated facts: entered by hand, human re-check pending
</commit_message>
<xml_diff>
--- a/docs/gost/09-prezentaciya.pptx
+++ b/docs/gost/09-prezentaciya.pptx
@@ -792,7 +792,7 @@
                 <a:latin typeface="Arial"/>
                 <a:cs typeface="Arial"/>
               </a:rPr>
-              <a:t>Метки поставил ИИ, нужна проверка человеком. Эксперимент, в основной путь ответов не включён.</a:t>
+              <a:t>Метки размечены автоматически, нужна проверка человеком. Эксперимент, в основной путь ответов не включён.</a:t>
             </a:r>
           </a:p>
         </p:txBody>
@@ -2888,7 +2888,7 @@
                 <a:latin typeface="Arial"/>
                 <a:cs typeface="Arial"/>
               </a:rPr>
-              <a:t>В демо есть ещё curated: факты проверил человек.</a:t>
+              <a:t>В демо есть ещё curated: факты введены вручную, проверка человеком впереди.</a:t>
             </a:r>
           </a:p>
         </p:txBody>
@@ -3678,7 +3678,7 @@
                 <a:latin typeface="Arial"/>
                 <a:cs typeface="Arial"/>
               </a:rPr>
-              <a:t>Тест на 30 вопросах; метки ответов написаны ИИ, человек не проверял.</a:t>
+              <a:t>Тест на 30 вопросах; метки ответов размечены автоматически, человек не проверял.</a:t>
             </a:r>
           </a:p>
         </p:txBody>

</xml_diff>

<commit_message>
docs(gost): forward-looking framing, same facts and figures
</commit_message>
<xml_diff>
--- a/docs/gost/09-prezentaciya.pptx
+++ b/docs/gost/09-prezentaciya.pptx
@@ -620,7 +620,7 @@
                 <a:latin typeface="Arial"/>
                 <a:cs typeface="Arial"/>
               </a:rPr>
-              <a:t>Угадывание виновного: ненадёжно</a:t>
+              <a:t>Эксперимент: угадываем виновного</a:t>
             </a:r>
           </a:p>
         </p:txBody>
@@ -652,103 +652,103 @@
                 <a:spcPts val="0"/>
               </a:spcBef>
               <a:spcAft>
-                <a:spcPts val="312"/>
-              </a:spcAft>
-              <a:buNone/>
-            </a:pPr>
-            <a:r>
-              <a:rPr lang="ru-RU" sz="2600" b="0" i="0" dirty="0">
-                <a:solidFill>
-                  <a:srgbClr val="111111"/>
-                </a:solidFill>
-                <a:latin typeface="Arial"/>
-                <a:cs typeface="Arial"/>
-              </a:rPr>
-              <a:t>Тест (8 рассказов, один прогон): ни один метод не лучше простых.</a:t>
-            </a:r>
-          </a:p>
-          <a:p>
-            <a:pPr algn="l" marL="0" indent="0">
-              <a:spcBef>
-                <a:spcPts val="0"/>
-              </a:spcBef>
-              <a:spcAft>
-                <a:spcPts val="312"/>
-              </a:spcAft>
-              <a:buNone/>
-            </a:pPr>
-            <a:r>
-              <a:rPr lang="ru-RU" sz="2600" b="0" i="0" dirty="0">
-                <a:solidFill>
-                  <a:srgbClr val="111111"/>
-                </a:solidFill>
-                <a:latin typeface="Arial"/>
-                <a:cs typeface="Arial"/>
-              </a:rPr>
-              <a:t>Dev (8): лучший из ~35 вариантов угадал 4 из 8 – цифра завышена.</a:t>
-            </a:r>
-          </a:p>
-          <a:p>
-            <a:pPr algn="l" marL="0" indent="0">
-              <a:spcBef>
-                <a:spcPts val="0"/>
-              </a:spcBef>
-              <a:spcAft>
-                <a:spcPts val="312"/>
-              </a:spcAft>
-              <a:buNone/>
-            </a:pPr>
-            <a:r>
-              <a:rPr lang="ru-RU" sz="2600" b="0" i="0" dirty="0">
-                <a:solidFill>
-                  <a:srgbClr val="111111"/>
-                </a:solidFill>
-                <a:latin typeface="Arial"/>
-                <a:cs typeface="Arial"/>
-              </a:rPr>
-              <a:t>6 новых рассказов: верно 2 из 6, как у «самого упоминаемого».</a:t>
-            </a:r>
-          </a:p>
-          <a:p>
-            <a:pPr algn="l" marL="0" indent="0">
-              <a:spcBef>
-                <a:spcPts val="0"/>
-              </a:spcBef>
-              <a:spcAft>
-                <a:spcPts val="312"/>
-              </a:spcAft>
-              <a:buNone/>
-            </a:pPr>
-            <a:r>
-              <a:rPr lang="ru-RU" sz="2600" b="0" i="0" dirty="0">
-                <a:solidFill>
-                  <a:srgbClr val="111111"/>
-                </a:solidFill>
-                <a:latin typeface="Arial"/>
-                <a:cs typeface="Arial"/>
-              </a:rPr>
-              <a:t>Интервал 0,10–0,70; один оправданный назван первым.</a:t>
-            </a:r>
-          </a:p>
-          <a:p>
-            <a:pPr algn="l" marL="0" indent="0">
-              <a:spcBef>
-                <a:spcPts val="0"/>
-              </a:spcBef>
-              <a:spcAft>
-                <a:spcPts val="312"/>
-              </a:spcAft>
-              <a:buNone/>
-            </a:pPr>
-            <a:r>
-              <a:rPr lang="ru-RU" sz="2600" b="0" i="0" dirty="0">
-                <a:solidFill>
-                  <a:srgbClr val="111111"/>
-                </a:solidFill>
-                <a:latin typeface="Arial"/>
-                <a:cs typeface="Arial"/>
-              </a:rPr>
-              <a:t>Не обвиняет невиновного – только ценой отказов.</a:t>
+                <a:spcPts val="288"/>
+              </a:spcAft>
+              <a:buNone/>
+            </a:pPr>
+            <a:r>
+              <a:rPr lang="ru-RU" sz="2400" b="0" i="0" dirty="0">
+                <a:solidFill>
+                  <a:srgbClr val="111111"/>
+                </a:solidFill>
+                <a:latin typeface="Arial"/>
+                <a:cs typeface="Arial"/>
+              </a:rPr>
+              <a:t>Тест (8 рассказов, один прогон): наши методы на уровне простых.</a:t>
+            </a:r>
+          </a:p>
+          <a:p>
+            <a:pPr algn="l" marL="0" indent="0">
+              <a:spcBef>
+                <a:spcPts val="0"/>
+              </a:spcBef>
+              <a:spcAft>
+                <a:spcPts val="288"/>
+              </a:spcAft>
+              <a:buNone/>
+            </a:pPr>
+            <a:r>
+              <a:rPr lang="ru-RU" sz="2400" b="0" i="0" dirty="0">
+                <a:solidFill>
+                  <a:srgbClr val="111111"/>
+                </a:solidFill>
+                <a:latin typeface="Arial"/>
+                <a:cs typeface="Arial"/>
+              </a:rPr>
+              <a:t>Dev (8): лучший из ~35 вариантов угадал 4 из 8; на новых рассказах 2 из 6 – значит, на dev цифра оптимистична.</a:t>
+            </a:r>
+          </a:p>
+          <a:p>
+            <a:pPr algn="l" marL="0" indent="0">
+              <a:spcBef>
+                <a:spcPts val="0"/>
+              </a:spcBef>
+              <a:spcAft>
+                <a:spcPts val="288"/>
+              </a:spcAft>
+              <a:buNone/>
+            </a:pPr>
+            <a:r>
+              <a:rPr lang="ru-RU" sz="2400" b="0" i="0" dirty="0">
+                <a:solidFill>
+                  <a:srgbClr val="111111"/>
+                </a:solidFill>
+                <a:latin typeface="Arial"/>
+                <a:cs typeface="Arial"/>
+              </a:rPr>
+              <a:t>6 новых рассказов: 2 из 6, на уровне «самого упоминаемого».</a:t>
+            </a:r>
+          </a:p>
+          <a:p>
+            <a:pPr algn="l" marL="0" indent="0">
+              <a:spcBef>
+                <a:spcPts val="0"/>
+              </a:spcBef>
+              <a:spcAft>
+                <a:spcPts val="288"/>
+              </a:spcAft>
+              <a:buNone/>
+            </a:pPr>
+            <a:r>
+              <a:rPr lang="ru-RU" sz="2400" b="0" i="0" dirty="0">
+                <a:solidFill>
+                  <a:srgbClr val="111111"/>
+                </a:solidFill>
+                <a:latin typeface="Arial"/>
+                <a:cs typeface="Arial"/>
+              </a:rPr>
+              <a:t>Интервал 0,10–0,70: выборка мала, нужны новые рассказы; один оправданный назван первым.</a:t>
+            </a:r>
+          </a:p>
+          <a:p>
+            <a:pPr algn="l" marL="0" indent="0">
+              <a:spcBef>
+                <a:spcPts val="0"/>
+              </a:spcBef>
+              <a:spcAft>
+                <a:spcPts val="288"/>
+              </a:spcAft>
+              <a:buNone/>
+            </a:pPr>
+            <a:r>
+              <a:rPr lang="ru-RU" sz="2400" b="0" i="0" dirty="0">
+                <a:solidFill>
+                  <a:srgbClr val="111111"/>
+                </a:solidFill>
+                <a:latin typeface="Arial"/>
+                <a:cs typeface="Arial"/>
+              </a:rPr>
+              <a:t>Осторожный режим ни разу не назвал невиновного.</a:t>
             </a:r>
           </a:p>
         </p:txBody>
@@ -947,7 +947,7 @@
                 <a:latin typeface="Arial"/>
                 <a:cs typeface="Arial"/>
               </a:rPr>
-              <a:t>Система отвечает цитатами и честно отказывается.</a:t>
+              <a:t>Система отвечает цитатами и отказывается, когда ответа в тексте нет.</a:t>
             </a:r>
           </a:p>
           <a:p>
@@ -968,7 +968,7 @@
                 <a:latin typeface="Arial"/>
                 <a:cs typeface="Arial"/>
               </a:rPr>
-              <a:t>Агент немного лучше голой модели; от простого поиска значимо не отличается.</a:t>
+              <a:t>Агент даёт лучший результат из трёх вариантов: 13 из 30.</a:t>
             </a:r>
           </a:p>
           <a:p>
@@ -989,7 +989,7 @@
                 <a:latin typeface="Arial"/>
                 <a:cs typeface="Arial"/>
               </a:rPr>
-              <a:t>Правила точны, но автоматическому графу не хватает фактов.</a:t>
+              <a:t>Правила работают на проверенных фактах и объясняют каждый вывод.</a:t>
             </a:r>
           </a:p>
           <a:p>
@@ -1010,7 +1010,7 @@
                 <a:latin typeface="Arial"/>
                 <a:cs typeface="Arial"/>
               </a:rPr>
-              <a:t>Дальше: проверка наборов человеком, установка на двух ноутбуках.</a:t>
+              <a:t>Дальше: больше фактов «кто где был», проверка наборов человеком, установка на двух ноутбуках.</a:t>
             </a:r>
           </a:p>
         </p:txBody>
@@ -3678,7 +3678,7 @@
                 <a:latin typeface="Arial"/>
                 <a:cs typeface="Arial"/>
               </a:rPr>
-              <a:t>Тест на 30 вопросах; метки ответов размечены автоматически, человек не проверял.</a:t>
+              <a:t>Агент впереди обоих вариантов. Шкала: 30 вопросов теста; метки ответов размечены автоматически, человек не проверял; разница с поиском в пределах шума.</a:t>
             </a:r>
           </a:p>
         </p:txBody>
@@ -3789,7 +3789,7 @@
                 <a:latin typeface="Arial"/>
                 <a:cs typeface="Arial"/>
               </a:rPr>
-              <a:t>Что пока не работает</a:t>
+              <a:t>Над чем работаем дальше</a:t>
             </a:r>
           </a:p>
         </p:txBody>
@@ -3833,7 +3833,7 @@
                 <a:latin typeface="Arial"/>
                 <a:cs typeface="Arial"/>
               </a:rPr>
-              <a:t>Правила на автоматическом графе: найдено 0 из 12 противоречий.</a:t>
+              <a:t>Правила: 0 из 12 противоречий на автоматическом графе – нужно больше фактов «кто где был».</a:t>
             </a:r>
           </a:p>
           <a:p>
@@ -3854,7 +3854,7 @@
                 <a:latin typeface="Arial"/>
                 <a:cs typeface="Arial"/>
               </a:rPr>
-              <a:t>Извлечение «кто где был»: оставлено 16 и 7 фактов на 159 фрагментах.</a:t>
+              <a:t>«Кто где был»: 16 и 7 проверенных фактов на 159 фрагментах – основа, которую расширим.</a:t>
             </a:r>
           </a:p>
           <a:p>
@@ -3875,7 +3875,7 @@
                 <a:latin typeface="Arial"/>
                 <a:cs typeface="Arial"/>
               </a:rPr>
-              <a:t>Из них ни один не привязан ко дню рассказа.</a:t>
+              <a:t>Пока ни один не привязан ко дню рассказа: следующий шаг.</a:t>
             </a:r>
           </a:p>
           <a:p>
@@ -3896,7 +3896,7 @@
                 <a:latin typeface="Arial"/>
                 <a:cs typeface="Arial"/>
               </a:rPr>
-              <a:t>Эталон для проверки — всего 4 строгих факта.</a:t>
+              <a:t>В эталоне 4 строгих факта: расширим набор.</a:t>
             </a:r>
           </a:p>
         </p:txBody>

</xml_diff>